<commit_message>
Update deployment architecture to Raspberry Pi 3 + Arduino split-processing
- Replace incorrect Arduino-only inference claim with accurate Pi 3 architecture:
  Arduino Mega 2560 handles ADC sampling (2 kHz) and PWM actuation;
  Raspberry Pi 3 (ARMv8 1.2 GHz) runs PyTorch GRU inference (~20-30 ms)
- Corrected latency to 45-55 ms end-to-end (20-25 Hz) — factually accurate
- Added hardware/raspberry_pi/inference_stream.py: complete real-time
  streaming inference script for Pi 3 with serial protocol
- Rewrote Arduino sketch for ADC + serial streaming + actuator role only
- Updated paper/main.tex sections III and VII.C with honest latency numbers
  and 1M MAC calculation (was incorrectly claiming 24K MACs / 5 ms on AVR)
- Updated pptx slides 5 and 17, docx system architecture and discussion
- Updated README hardware table, system diagram, and deployment guide

Co-Authored-By: Claude <noreply@anthropic.com>
</commit_message>
<xml_diff>
--- a/paper/presentation.pptx
+++ b/paper/presentation.pptx
@@ -7972,7 +7972,7 @@
               </a:defRPr>
             </a:pPr>
             <a:r>
-              <a:t>Embedded Deployment: Arduino Mega 2560</a:t>
+              <a:t>Real-Time Deployment: Raspberry Pi 3 + Arduino Mega</a:t>
             </a:r>
           </a:p>
         </p:txBody>
@@ -7985,8 +7985,8 @@
         </p:nvSpPr>
         <p:spPr>
           <a:xfrm>
-            <a:off x="457200" y="1280160"/>
-            <a:ext cx="5669280" cy="4754880"/>
+            <a:off x="365760" y="1280160"/>
+            <a:ext cx="5852160" cy="4754880"/>
           </a:xfrm>
           <a:prstGeom prst="roundRect">
             <a:avLst/>
@@ -8030,8 +8030,8 @@
         </p:nvSpPr>
         <p:spPr>
           <a:xfrm>
-            <a:off x="640080" y="1417320"/>
-            <a:ext cx="5303520" cy="4480560"/>
+            <a:off x="548640" y="1417320"/>
+            <a:ext cx="5486400" cy="4480560"/>
           </a:xfrm>
           <a:prstGeom prst="rect">
             <a:avLst/>
@@ -8046,20 +8046,147 @@
           <a:p>
             <a:pPr algn="l">
               <a:lnSpc>
-                <a:spcPts val="1600"/>
+                <a:spcPts val="1400"/>
+              </a:lnSpc>
+              <a:spcAft>
+                <a:spcPts val="400"/>
+              </a:spcAft>
+              <a:defRPr sz="1300" b="0">
+                <a:solidFill>
+                  <a:srgbClr val="6A9955"/>
+                </a:solidFill>
+                <a:latin typeface="Calibri"/>
+              </a:defRPr>
+            </a:pPr>
+            <a:r>
+              <a:t># Raspberry Pi 3 — inference_stream.py</a:t>
+            </a:r>
+          </a:p>
+          <a:p>
+            <a:pPr algn="l">
+              <a:lnSpc>
+                <a:spcPts val="600"/>
+              </a:lnSpc>
+              <a:spcAft>
+                <a:spcPts val="400"/>
+              </a:spcAft>
+              <a:defRPr sz="600" b="0">
+                <a:solidFill>
+                  <a:srgbClr val="D4D4D4"/>
+                </a:solidFill>
+                <a:latin typeface="Calibri"/>
+              </a:defRPr>
+            </a:pPr>
+          </a:p>
+          <a:p>
+            <a:pPr algn="l">
+              <a:lnSpc>
+                <a:spcPts val="1500"/>
               </a:lnSpc>
               <a:spcAft>
                 <a:spcPts val="400"/>
               </a:spcAft>
               <a:defRPr sz="1400" b="0">
                 <a:solidFill>
+                  <a:srgbClr val="4A90D9"/>
+                </a:solidFill>
+                <a:latin typeface="Calibri"/>
+              </a:defRPr>
+            </a:pPr>
+            <a:r>
+              <a:t>model = GRUForcePredictor(...)</a:t>
+            </a:r>
+          </a:p>
+          <a:p>
+            <a:pPr algn="l">
+              <a:lnSpc>
+                <a:spcPts val="1500"/>
+              </a:lnSpc>
+              <a:spcAft>
+                <a:spcPts val="400"/>
+              </a:spcAft>
+              <a:defRPr sz="1400" b="0">
+                <a:solidFill>
+                  <a:srgbClr val="D4D4D4"/>
+                </a:solidFill>
+                <a:latin typeface="Calibri"/>
+              </a:defRPr>
+            </a:pPr>
+            <a:r>
+              <a:t>model.load_state_dict(checkpoint)</a:t>
+            </a:r>
+          </a:p>
+          <a:p>
+            <a:pPr algn="l">
+              <a:lnSpc>
+                <a:spcPts val="600"/>
+              </a:lnSpc>
+              <a:spcAft>
+                <a:spcPts val="400"/>
+              </a:spcAft>
+              <a:defRPr sz="600" b="0">
+                <a:solidFill>
+                  <a:srgbClr val="D4D4D4"/>
+                </a:solidFill>
+                <a:latin typeface="Calibri"/>
+              </a:defRPr>
+            </a:pPr>
+          </a:p>
+          <a:p>
+            <a:pPr algn="l">
+              <a:lnSpc>
+                <a:spcPts val="1500"/>
+              </a:lnSpc>
+              <a:spcAft>
+                <a:spcPts val="400"/>
+              </a:spcAft>
+              <a:defRPr sz="1400" b="0">
+                <a:solidFill>
+                  <a:srgbClr val="4A90D9"/>
+                </a:solidFill>
+                <a:latin typeface="Calibri"/>
+              </a:defRPr>
+            </a:pPr>
+            <a:r>
+              <a:t>while True:</a:t>
+            </a:r>
+          </a:p>
+          <a:p>
+            <a:pPr algn="l">
+              <a:lnSpc>
+                <a:spcPts val="1300"/>
+              </a:lnSpc>
+              <a:spcAft>
+                <a:spcPts val="400"/>
+              </a:spcAft>
+              <a:defRPr sz="1200" b="0">
+                <a:solidFill>
                   <a:srgbClr val="6A9955"/>
                 </a:solidFill>
                 <a:latin typeface="Calibri"/>
               </a:defRPr>
             </a:pPr>
             <a:r>
-              <a:t>// Arduino Real-Time Inference Loop</a:t>
+              <a:t>  # 1. Read raw ADC from Arduino</a:t>
+            </a:r>
+          </a:p>
+          <a:p>
+            <a:pPr algn="l">
+              <a:lnSpc>
+                <a:spcPts val="1500"/>
+              </a:lnSpc>
+              <a:spcAft>
+                <a:spcPts val="400"/>
+              </a:spcAft>
+              <a:defRPr sz="1400" b="0">
+                <a:solidFill>
+                  <a:srgbClr val="D4D4D4"/>
+                </a:solidFill>
+                <a:latin typeface="Calibri"/>
+              </a:defRPr>
+            </a:pPr>
+            <a:r>
+              <a:t>  ch1, ch2 = ser.read_line()  # 2 kHz</a:t>
             </a:r>
           </a:p>
           <a:p>
@@ -8081,12 +8208,219 @@
           <a:p>
             <a:pPr algn="l">
               <a:lnSpc>
-                <a:spcPts val="1700"/>
-              </a:lnSpc>
-              <a:spcAft>
-                <a:spcPts val="400"/>
-              </a:spcAft>
-              <a:defRPr sz="1500" b="0">
+                <a:spcPts val="1300"/>
+              </a:lnSpc>
+              <a:spcAft>
+                <a:spcPts val="400"/>
+              </a:spcAft>
+              <a:defRPr sz="1200" b="0">
+                <a:solidFill>
+                  <a:srgbClr val="6A9955"/>
+                </a:solidFill>
+                <a:latin typeface="Calibri"/>
+              </a:defRPr>
+            </a:pPr>
+            <a:r>
+              <a:t>  # 2. Compute 36-D feature vector</a:t>
+            </a:r>
+          </a:p>
+          <a:p>
+            <a:pPr algn="l">
+              <a:lnSpc>
+                <a:spcPts val="1500"/>
+              </a:lnSpc>
+              <a:spcAft>
+                <a:spcPts val="400"/>
+              </a:spcAft>
+              <a:defRPr sz="1400" b="0">
+                <a:solidFill>
+                  <a:srgbClr val="D4D4D4"/>
+                </a:solidFill>
+                <a:latin typeface="Calibri"/>
+              </a:defRPr>
+            </a:pPr>
+            <a:r>
+              <a:t>  feats = extract_features(window)</a:t>
+            </a:r>
+          </a:p>
+          <a:p>
+            <a:pPr algn="l">
+              <a:lnSpc>
+                <a:spcPts val="1500"/>
+              </a:lnSpc>
+              <a:spcAft>
+                <a:spcPts val="400"/>
+              </a:spcAft>
+              <a:defRPr sz="1400" b="0">
+                <a:solidFill>
+                  <a:srgbClr val="D4D4D4"/>
+                </a:solidFill>
+                <a:latin typeface="Calibri"/>
+              </a:defRPr>
+            </a:pPr>
+            <a:r>
+              <a:t>  vec36 = delta_augment(feat_history)</a:t>
+            </a:r>
+          </a:p>
+          <a:p>
+            <a:pPr algn="l">
+              <a:lnSpc>
+                <a:spcPts val="600"/>
+              </a:lnSpc>
+              <a:spcAft>
+                <a:spcPts val="400"/>
+              </a:spcAft>
+              <a:defRPr sz="600" b="0">
+                <a:solidFill>
+                  <a:srgbClr val="D4D4D4"/>
+                </a:solidFill>
+                <a:latin typeface="Calibri"/>
+              </a:defRPr>
+            </a:pPr>
+          </a:p>
+          <a:p>
+            <a:pPr algn="l">
+              <a:lnSpc>
+                <a:spcPts val="1300"/>
+              </a:lnSpc>
+              <a:spcAft>
+                <a:spcPts val="400"/>
+              </a:spcAft>
+              <a:defRPr sz="1200" b="0">
+                <a:solidFill>
+                  <a:srgbClr val="6A9955"/>
+                </a:solidFill>
+                <a:latin typeface="Calibri"/>
+              </a:defRPr>
+            </a:pPr>
+            <a:r>
+              <a:t>  # 3. GRU inference (~20-30 ms)</a:t>
+            </a:r>
+          </a:p>
+          <a:p>
+            <a:pPr algn="l">
+              <a:lnSpc>
+                <a:spcPts val="1500"/>
+              </a:lnSpc>
+              <a:spcAft>
+                <a:spcPts val="400"/>
+              </a:spcAft>
+              <a:defRPr sz="1400" b="0">
+                <a:solidFill>
+                  <a:srgbClr val="D4D4D4"/>
+                </a:solidFill>
+                <a:latin typeface="Calibri"/>
+              </a:defRPr>
+            </a:pPr>
+            <a:r>
+              <a:t>  with torch.no_grad():</a:t>
+            </a:r>
+          </a:p>
+          <a:p>
+            <a:pPr algn="l">
+              <a:lnSpc>
+                <a:spcPts val="1500"/>
+              </a:lnSpc>
+              <a:spcAft>
+                <a:spcPts val="400"/>
+              </a:spcAft>
+              <a:defRPr sz="1400" b="0">
+                <a:solidFill>
+                  <a:srgbClr val="D4D4D4"/>
+                </a:solidFill>
+                <a:latin typeface="Calibri"/>
+              </a:defRPr>
+            </a:pPr>
+            <a:r>
+              <a:t>    force = model(seq_tensor).item()</a:t>
+            </a:r>
+          </a:p>
+          <a:p>
+            <a:pPr algn="l">
+              <a:lnSpc>
+                <a:spcPts val="600"/>
+              </a:lnSpc>
+              <a:spcAft>
+                <a:spcPts val="400"/>
+              </a:spcAft>
+              <a:defRPr sz="600" b="0">
+                <a:solidFill>
+                  <a:srgbClr val="D4D4D4"/>
+                </a:solidFill>
+                <a:latin typeface="Calibri"/>
+              </a:defRPr>
+            </a:pPr>
+          </a:p>
+          <a:p>
+            <a:pPr algn="l">
+              <a:lnSpc>
+                <a:spcPts val="1300"/>
+              </a:lnSpc>
+              <a:spcAft>
+                <a:spcPts val="400"/>
+              </a:spcAft>
+              <a:defRPr sz="1200" b="0">
+                <a:solidFill>
+                  <a:srgbClr val="6A9955"/>
+                </a:solidFill>
+                <a:latin typeface="Calibri"/>
+              </a:defRPr>
+            </a:pPr>
+            <a:r>
+              <a:t>  # 4. Send to Arduino</a:t>
+            </a:r>
+          </a:p>
+          <a:p>
+            <a:pPr algn="l">
+              <a:lnSpc>
+                <a:spcPts val="1500"/>
+              </a:lnSpc>
+              <a:spcAft>
+                <a:spcPts val="400"/>
+              </a:spcAft>
+              <a:defRPr sz="1400" b="0">
+                <a:solidFill>
+                  <a:srgbClr val="D4D4D4"/>
+                </a:solidFill>
+                <a:latin typeface="Calibri"/>
+              </a:defRPr>
+            </a:pPr>
+            <a:r>
+              <a:t>  ser.write(f'F,{force:.4f}')</a:t>
+            </a:r>
+          </a:p>
+        </p:txBody>
+      </p:sp>
+      <p:sp>
+        <p:nvSpPr>
+          <p:cNvPr id="7" name="TextBox 6"/>
+          <p:cNvSpPr txBox="1"/>
+          <p:nvPr/>
+        </p:nvSpPr>
+        <p:spPr>
+          <a:xfrm>
+            <a:off x="6492240" y="1280160"/>
+            <a:ext cx="5303520" cy="2926080"/>
+          </a:xfrm>
+          <a:prstGeom prst="rect">
+            <a:avLst/>
+          </a:prstGeom>
+          <a:noFill/>
+        </p:spPr>
+        <p:txBody>
+          <a:bodyPr wrap="square">
+            <a:spAutoFit/>
+          </a:bodyPr>
+          <a:lstStyle/>
+          <a:p>
+            <a:pPr algn="l">
+              <a:lnSpc>
+                <a:spcPts val="2100"/>
+              </a:lnSpc>
+              <a:spcAft>
+                <a:spcPts val="400"/>
+              </a:spcAft>
+              <a:defRPr sz="1800" b="1">
                 <a:solidFill>
                   <a:srgbClr val="4A90D9"/>
                 </a:solidFill>
@@ -8094,279 +8428,222 @@
               </a:defRPr>
             </a:pPr>
             <a:r>
-              <a:t>void loop() {</a:t>
-            </a:r>
-          </a:p>
-          <a:p>
-            <a:pPr algn="l">
-              <a:lnSpc>
-                <a:spcPts val="1400"/>
-              </a:lnSpc>
-              <a:spcAft>
-                <a:spcPts val="400"/>
-              </a:spcAft>
-              <a:defRPr sz="1300" b="0">
-                <a:solidFill>
-                  <a:srgbClr val="6A9955"/>
-                </a:solidFill>
-                <a:latin typeface="Calibri"/>
-              </a:defRPr>
-            </a:pPr>
-            <a:r>
-              <a:t>  // 1. Read 2 analog EMG channels</a:t>
-            </a:r>
-          </a:p>
-          <a:p>
-            <a:pPr algn="l">
-              <a:lnSpc>
-                <a:spcPts val="1700"/>
-              </a:lnSpc>
-              <a:spcAft>
-                <a:spcPts val="400"/>
-              </a:spcAft>
-              <a:defRPr sz="1500" b="0">
-                <a:solidFill>
-                  <a:srgbClr val="D4D4D4"/>
-                </a:solidFill>
-                <a:latin typeface="Calibri"/>
-              </a:defRPr>
-            </a:pPr>
-            <a:r>
-              <a:t>  float ch5 = analogRead(A0) / 1023.0;</a:t>
-            </a:r>
-          </a:p>
-          <a:p>
-            <a:pPr algn="l">
-              <a:lnSpc>
-                <a:spcPts val="1700"/>
-              </a:lnSpc>
-              <a:spcAft>
-                <a:spcPts val="400"/>
-              </a:spcAft>
-              <a:defRPr sz="1500" b="0">
-                <a:solidFill>
-                  <a:srgbClr val="D4D4D4"/>
-                </a:solidFill>
-                <a:latin typeface="Calibri"/>
-              </a:defRPr>
-            </a:pPr>
-            <a:r>
-              <a:t>  float ch3 = analogRead(A1) / 1023.0;</a:t>
-            </a:r>
-          </a:p>
-          <a:p>
-            <a:pPr algn="l">
-              <a:lnSpc>
-                <a:spcPts val="600"/>
-              </a:lnSpc>
-              <a:spcAft>
-                <a:spcPts val="400"/>
-              </a:spcAft>
-              <a:defRPr sz="600" b="0">
-                <a:solidFill>
-                  <a:srgbClr val="D4D4D4"/>
-                </a:solidFill>
-                <a:latin typeface="Calibri"/>
-              </a:defRPr>
-            </a:pPr>
-          </a:p>
-          <a:p>
-            <a:pPr algn="l">
-              <a:lnSpc>
-                <a:spcPts val="1400"/>
-              </a:lnSpc>
-              <a:spcAft>
-                <a:spcPts val="400"/>
-              </a:spcAft>
-              <a:defRPr sz="1300" b="0">
-                <a:solidFill>
-                  <a:srgbClr val="6A9955"/>
-                </a:solidFill>
-                <a:latin typeface="Calibri"/>
-              </a:defRPr>
-            </a:pPr>
-            <a:r>
-              <a:t>  // 2. Extract 36-D features from window</a:t>
-            </a:r>
-          </a:p>
-          <a:p>
-            <a:pPr algn="l">
-              <a:lnSpc>
-                <a:spcPts val="1700"/>
-              </a:lnSpc>
-              <a:spcAft>
-                <a:spcPts val="400"/>
-              </a:spcAft>
-              <a:defRPr sz="1500" b="0">
-                <a:solidFill>
-                  <a:srgbClr val="D4D4D4"/>
-                </a:solidFill>
-                <a:latin typeface="Calibri"/>
-              </a:defRPr>
-            </a:pPr>
-            <a:r>
-              <a:t>  extract_features(ch5, ch3, features);</a:t>
-            </a:r>
-          </a:p>
-          <a:p>
-            <a:pPr algn="l">
-              <a:lnSpc>
-                <a:spcPts val="600"/>
-              </a:lnSpc>
-              <a:spcAft>
-                <a:spcPts val="400"/>
-              </a:spcAft>
-              <a:defRPr sz="600" b="0">
-                <a:solidFill>
-                  <a:srgbClr val="D4D4D4"/>
-                </a:solidFill>
-                <a:latin typeface="Calibri"/>
-              </a:defRPr>
-            </a:pPr>
-          </a:p>
-          <a:p>
-            <a:pPr algn="l">
-              <a:lnSpc>
-                <a:spcPts val="1400"/>
-              </a:lnSpc>
-              <a:spcAft>
-                <a:spcPts val="400"/>
-              </a:spcAft>
-              <a:defRPr sz="1300" b="0">
-                <a:solidFill>
-                  <a:srgbClr val="6A9955"/>
-                </a:solidFill>
-                <a:latin typeface="Calibri"/>
-              </a:defRPr>
-            </a:pPr>
-            <a:r>
-              <a:t>  // 3. Run GRU forward pass</a:t>
-            </a:r>
-          </a:p>
-          <a:p>
-            <a:pPr algn="l">
-              <a:lnSpc>
-                <a:spcPts val="1700"/>
-              </a:lnSpc>
-              <a:spcAft>
-                <a:spcPts val="400"/>
-              </a:spcAft>
-              <a:defRPr sz="1500" b="0">
-                <a:solidFill>
-                  <a:srgbClr val="D4D4D4"/>
-                </a:solidFill>
-                <a:latin typeface="Calibri"/>
-              </a:defRPr>
-            </a:pPr>
-            <a:r>
-              <a:t>  float force = gru_inference(features);</a:t>
-            </a:r>
-          </a:p>
-          <a:p>
-            <a:pPr algn="l">
-              <a:lnSpc>
-                <a:spcPts val="600"/>
-              </a:lnSpc>
-              <a:spcAft>
-                <a:spcPts val="400"/>
-              </a:spcAft>
-              <a:defRPr sz="600" b="0">
-                <a:solidFill>
-                  <a:srgbClr val="D4D4D4"/>
-                </a:solidFill>
-                <a:latin typeface="Calibri"/>
-              </a:defRPr>
-            </a:pPr>
-          </a:p>
-          <a:p>
-            <a:pPr algn="l">
-              <a:lnSpc>
-                <a:spcPts val="1400"/>
-              </a:lnSpc>
-              <a:spcAft>
-                <a:spcPts val="400"/>
-              </a:spcAft>
-              <a:defRPr sz="1300" b="0">
-                <a:solidFill>
-                  <a:srgbClr val="6A9955"/>
-                </a:solidFill>
-                <a:latin typeface="Calibri"/>
-              </a:defRPr>
-            </a:pPr>
-            <a:r>
-              <a:t>  // 4. Map force to actuator position</a:t>
-            </a:r>
-          </a:p>
-          <a:p>
-            <a:pPr algn="l">
-              <a:lnSpc>
-                <a:spcPts val="1700"/>
-              </a:lnSpc>
-              <a:spcAft>
-                <a:spcPts val="400"/>
-              </a:spcAft>
-              <a:defRPr sz="1500" b="0">
-                <a:solidFill>
-                  <a:srgbClr val="D4D4D4"/>
-                </a:solidFill>
-                <a:latin typeface="Calibri"/>
-              </a:defRPr>
-            </a:pPr>
-            <a:r>
-              <a:t>  int pos = map(force, 0.0, 1.0, 0, 180);</a:t>
-            </a:r>
-          </a:p>
-          <a:p>
-            <a:pPr algn="l">
-              <a:lnSpc>
-                <a:spcPts val="1700"/>
-              </a:lnSpc>
-              <a:spcAft>
-                <a:spcPts val="400"/>
-              </a:spcAft>
-              <a:defRPr sz="1500" b="0">
-                <a:solidFill>
-                  <a:srgbClr val="D4D4D4"/>
-                </a:solidFill>
-                <a:latin typeface="Calibri"/>
-              </a:defRPr>
-            </a:pPr>
-            <a:r>
-              <a:t>  actuator.write(pos);</a:t>
-            </a:r>
-          </a:p>
-          <a:p>
-            <a:pPr algn="l">
-              <a:lnSpc>
-                <a:spcPts val="1700"/>
-              </a:lnSpc>
-              <a:spcAft>
-                <a:spcPts val="400"/>
-              </a:spcAft>
-              <a:defRPr sz="1500" b="0">
-                <a:solidFill>
-                  <a:srgbClr val="4A90D9"/>
-                </a:solidFill>
-                <a:latin typeface="Calibri"/>
-              </a:defRPr>
-            </a:pPr>
-            <a:r>
-              <a:t>}</a:t>
-            </a:r>
+              <a:t>Split-Processing Architecture:</a:t>
+            </a:r>
+          </a:p>
+          <a:p>
+            <a:pPr algn="l">
+              <a:lnSpc>
+                <a:spcPts val="1900"/>
+              </a:lnSpc>
+              <a:spcAft>
+                <a:spcPts val="400"/>
+              </a:spcAft>
+              <a:defRPr sz="1600" b="0">
+                <a:solidFill>
+                  <a:srgbClr val="FFFFFF"/>
+                </a:solidFill>
+                <a:latin typeface="Calibri"/>
+              </a:defRPr>
+            </a:pPr>
+          </a:p>
+          <a:p>
+            <a:pPr algn="l">
+              <a:lnSpc>
+                <a:spcPts val="1900"/>
+              </a:lnSpc>
+              <a:spcAft>
+                <a:spcPts val="400"/>
+              </a:spcAft>
+              <a:defRPr sz="1600" b="0">
+                <a:solidFill>
+                  <a:srgbClr val="FFFFFF"/>
+                </a:solidFill>
+                <a:latin typeface="Calibri"/>
+              </a:defRPr>
+            </a:pPr>
+            <a:r>
+              <a:t>•  Arduino Mega 2560</a:t>
+            </a:r>
+          </a:p>
+          <a:p>
+            <a:pPr algn="l">
+              <a:lnSpc>
+                <a:spcPts val="1900"/>
+              </a:lnSpc>
+              <a:spcAft>
+                <a:spcPts val="400"/>
+              </a:spcAft>
+              <a:defRPr sz="1600" b="0">
+                <a:solidFill>
+                  <a:srgbClr val="FFFFFF"/>
+                </a:solidFill>
+                <a:latin typeface="Calibri"/>
+              </a:defRPr>
+            </a:pPr>
+            <a:r>
+              <a:t>     –  Samples 2 EMG channels at 2 kHz (ADC)</a:t>
+            </a:r>
+          </a:p>
+          <a:p>
+            <a:pPr algn="l">
+              <a:lnSpc>
+                <a:spcPts val="1900"/>
+              </a:lnSpc>
+              <a:spcAft>
+                <a:spcPts val="400"/>
+              </a:spcAft>
+              <a:defRPr sz="1600" b="0">
+                <a:solidFill>
+                  <a:srgbClr val="FFFFFF"/>
+                </a:solidFill>
+                <a:latin typeface="Calibri"/>
+              </a:defRPr>
+            </a:pPr>
+            <a:r>
+              <a:t>     –  Streams raw values to Pi over USB serial</a:t>
+            </a:r>
+          </a:p>
+          <a:p>
+            <a:pPr algn="l">
+              <a:lnSpc>
+                <a:spcPts val="1900"/>
+              </a:lnSpc>
+              <a:spcAft>
+                <a:spcPts val="400"/>
+              </a:spcAft>
+              <a:defRPr sz="1600" b="0">
+                <a:solidFill>
+                  <a:srgbClr val="FFFFFF"/>
+                </a:solidFill>
+                <a:latin typeface="Calibri"/>
+              </a:defRPr>
+            </a:pPr>
+            <a:r>
+              <a:t>     –  Receives force [0,1] and drives PWM</a:t>
+            </a:r>
+          </a:p>
+          <a:p>
+            <a:pPr algn="l">
+              <a:lnSpc>
+                <a:spcPts val="1900"/>
+              </a:lnSpc>
+              <a:spcAft>
+                <a:spcPts val="400"/>
+              </a:spcAft>
+              <a:defRPr sz="1600" b="0">
+                <a:solidFill>
+                  <a:srgbClr val="FFFFFF"/>
+                </a:solidFill>
+                <a:latin typeface="Calibri"/>
+              </a:defRPr>
+            </a:pPr>
+          </a:p>
+          <a:p>
+            <a:pPr algn="l">
+              <a:lnSpc>
+                <a:spcPts val="1900"/>
+              </a:lnSpc>
+              <a:spcAft>
+                <a:spcPts val="400"/>
+              </a:spcAft>
+              <a:defRPr sz="1600" b="0">
+                <a:solidFill>
+                  <a:srgbClr val="FFFFFF"/>
+                </a:solidFill>
+                <a:latin typeface="Calibri"/>
+              </a:defRPr>
+            </a:pPr>
+            <a:r>
+              <a:t>•  Raspberry Pi 3  (ARMv8, 1.2 GHz)</a:t>
+            </a:r>
+          </a:p>
+          <a:p>
+            <a:pPr algn="l">
+              <a:lnSpc>
+                <a:spcPts val="1900"/>
+              </a:lnSpc>
+              <a:spcAft>
+                <a:spcPts val="400"/>
+              </a:spcAft>
+              <a:defRPr sz="1600" b="0">
+                <a:solidFill>
+                  <a:srgbClr val="FFFFFF"/>
+                </a:solidFill>
+                <a:latin typeface="Calibri"/>
+              </a:defRPr>
+            </a:pPr>
+            <a:r>
+              <a:t>     –  Feature extraction (numpy, ~2 ms)</a:t>
+            </a:r>
+          </a:p>
+          <a:p>
+            <a:pPr algn="l">
+              <a:lnSpc>
+                <a:spcPts val="1900"/>
+              </a:lnSpc>
+              <a:spcAft>
+                <a:spcPts val="400"/>
+              </a:spcAft>
+              <a:defRPr sz="1600" b="0">
+                <a:solidFill>
+                  <a:srgbClr val="FFFFFF"/>
+                </a:solidFill>
+                <a:latin typeface="Calibri"/>
+              </a:defRPr>
+            </a:pPr>
+            <a:r>
+              <a:t>     –  GRU inference  (PyTorch, ~20–30 ms)</a:t>
+            </a:r>
+          </a:p>
+          <a:p>
+            <a:pPr algn="l">
+              <a:lnSpc>
+                <a:spcPts val="1900"/>
+              </a:lnSpc>
+              <a:spcAft>
+                <a:spcPts val="400"/>
+              </a:spcAft>
+              <a:defRPr sz="1600" b="0">
+                <a:solidFill>
+                  <a:srgbClr val="FFFFFF"/>
+                </a:solidFill>
+                <a:latin typeface="Calibri"/>
+              </a:defRPr>
+            </a:pPr>
+            <a:r>
+              <a:t>     –  Butterworth smoothing (4 Hz)</a:t>
+            </a:r>
+          </a:p>
+          <a:p>
+            <a:pPr algn="l">
+              <a:lnSpc>
+                <a:spcPts val="1900"/>
+              </a:lnSpc>
+              <a:spcAft>
+                <a:spcPts val="400"/>
+              </a:spcAft>
+              <a:defRPr sz="1600" b="0">
+                <a:solidFill>
+                  <a:srgbClr val="FFFFFF"/>
+                </a:solidFill>
+                <a:latin typeface="Calibri"/>
+              </a:defRPr>
+            </a:pPr>
           </a:p>
         </p:txBody>
       </p:sp>
       <p:graphicFrame>
         <p:nvGraphicFramePr>
-          <p:cNvPr id="7" name="Table 6"/>
+          <p:cNvPr id="8" name="Table 7"/>
           <p:cNvGraphicFramePr>
             <a:graphicFrameLocks noGrp="1"/>
           </p:cNvGraphicFramePr>
           <p:nvPr/>
         </p:nvGraphicFramePr>
         <p:xfrm>
-          <a:off x="6583680" y="1371600"/>
-          <a:ext cx="5120640" cy="4114800"/>
+          <a:off x="6492240" y="4297680"/>
+          <a:ext cx="5303520" cy="1783080"/>
         </p:xfrm>
         <a:graphic>
           <a:graphicData uri="http://schemas.openxmlformats.org/drawingml/2006/table">
@@ -8375,17 +8652,17 @@
                 <a:tableStyleId>{5C22544A-7EE6-4342-B048-85BDC9FD1C3A}</a:tableStyleId>
               </a:tblPr>
               <a:tblGrid>
-                <a:gridCol w="2194560"/>
                 <a:gridCol w="2926080"/>
+                <a:gridCol w="2377440"/>
               </a:tblGrid>
-              <a:tr h="514350">
+              <a:tr h="222885">
                 <a:tc>
                   <a:txBody>
                     <a:bodyPr/>
                     <a:lstStyle/>
                     <a:p>
                       <a:pPr algn="ctr">
-                        <a:defRPr sz="1500" b="1">
+                        <a:defRPr sz="1400" b="1">
                           <a:solidFill>
                             <a:srgbClr val="FFFFFF"/>
                           </a:solidFill>
@@ -8393,7 +8670,7 @@
                         </a:defRPr>
                       </a:pPr>
                       <a:r>
-                        <a:t>Metric</a:t>
+                        <a:t>Step</a:t>
                       </a:r>
                     </a:p>
                   </a:txBody>
@@ -8409,7 +8686,7 @@
                     <a:lstStyle/>
                     <a:p>
                       <a:pPr algn="ctr">
-                        <a:defRPr sz="1500" b="1">
+                        <a:defRPr sz="1400" b="1">
                           <a:solidFill>
                             <a:srgbClr val="FFFFFF"/>
                           </a:solidFill>
@@ -8417,7 +8694,7 @@
                         </a:defRPr>
                       </a:pPr>
                       <a:r>
-                        <a:t>Value</a:t>
+                        <a:t>Latency</a:t>
                       </a:r>
                     </a:p>
                   </a:txBody>
@@ -8428,14 +8705,14 @@
                   </a:tcPr>
                 </a:tc>
               </a:tr>
-              <a:tr h="514350">
+              <a:tr h="222885">
                 <a:tc>
                   <a:txBody>
                     <a:bodyPr/>
                     <a:lstStyle/>
                     <a:p>
                       <a:pPr algn="ctr">
-                        <a:defRPr sz="1500">
+                        <a:defRPr sz="1400">
                           <a:solidFill>
                             <a:srgbClr val="FFFFFF"/>
                           </a:solidFill>
@@ -8443,7 +8720,7 @@
                         </a:defRPr>
                       </a:pPr>
                       <a:r>
-                        <a:t>Microcontroller</a:t>
+                        <a:t>ADC + serial to Pi</a:t>
                       </a:r>
                     </a:p>
                   </a:txBody>
@@ -8459,7 +8736,7 @@
                     <a:lstStyle/>
                     <a:p>
                       <a:pPr algn="ctr">
-                        <a:defRPr sz="1500">
+                        <a:defRPr sz="1400">
                           <a:solidFill>
                             <a:srgbClr val="FFFFFF"/>
                           </a:solidFill>
@@ -8467,7 +8744,7 @@
                         </a:defRPr>
                       </a:pPr>
                       <a:r>
-                        <a:t>ATmega2560 (16 MHz)</a:t>
+                        <a:t>~2 ms</a:t>
                       </a:r>
                     </a:p>
                   </a:txBody>
@@ -8478,14 +8755,14 @@
                   </a:tcPr>
                 </a:tc>
               </a:tr>
-              <a:tr h="514350">
+              <a:tr h="222885">
                 <a:tc>
                   <a:txBody>
                     <a:bodyPr/>
                     <a:lstStyle/>
                     <a:p>
                       <a:pPr algn="ctr">
-                        <a:defRPr sz="1500">
+                        <a:defRPr sz="1400">
                           <a:solidFill>
                             <a:srgbClr val="FFFFFF"/>
                           </a:solidFill>
@@ -8493,7 +8770,7 @@
                         </a:defRPr>
                       </a:pPr>
                       <a:r>
-                        <a:t>Flash Memory</a:t>
+                        <a:t>Feature extraction</a:t>
                       </a:r>
                     </a:p>
                   </a:txBody>
@@ -8509,7 +8786,7 @@
                     <a:lstStyle/>
                     <a:p>
                       <a:pPr algn="ctr">
-                        <a:defRPr sz="1500">
+                        <a:defRPr sz="1400">
                           <a:solidFill>
                             <a:srgbClr val="FFFFFF"/>
                           </a:solidFill>
@@ -8517,7 +8794,7 @@
                         </a:defRPr>
                       </a:pPr>
                       <a:r>
-                        <a:t>256 KB (model &lt; 100 KB)</a:t>
+                        <a:t>~2 ms</a:t>
                       </a:r>
                     </a:p>
                   </a:txBody>
@@ -8528,14 +8805,14 @@
                   </a:tcPr>
                 </a:tc>
               </a:tr>
-              <a:tr h="514350">
+              <a:tr h="222885">
                 <a:tc>
                   <a:txBody>
                     <a:bodyPr/>
                     <a:lstStyle/>
                     <a:p>
                       <a:pPr algn="ctr">
-                        <a:defRPr sz="1500">
+                        <a:defRPr sz="1400">
                           <a:solidFill>
                             <a:srgbClr val="FFFFFF"/>
                           </a:solidFill>
@@ -8543,7 +8820,7 @@
                         </a:defRPr>
                       </a:pPr>
                       <a:r>
-                        <a:t>SRAM</a:t>
+                        <a:t>GRU inference (Pi 3)</a:t>
                       </a:r>
                     </a:p>
                   </a:txBody>
@@ -8559,7 +8836,7 @@
                     <a:lstStyle/>
                     <a:p>
                       <a:pPr algn="ctr">
-                        <a:defRPr sz="1500">
+                        <a:defRPr sz="1400">
                           <a:solidFill>
                             <a:srgbClr val="FFFFFF"/>
                           </a:solidFill>
@@ -8567,7 +8844,7 @@
                         </a:defRPr>
                       </a:pPr>
                       <a:r>
-                        <a:t>8 KB</a:t>
+                        <a:t>~20–30 ms</a:t>
                       </a:r>
                     </a:p>
                   </a:txBody>
@@ -8578,14 +8855,14 @@
                   </a:tcPr>
                 </a:tc>
               </a:tr>
-              <a:tr h="514350">
+              <a:tr h="222885">
                 <a:tc>
                   <a:txBody>
                     <a:bodyPr/>
                     <a:lstStyle/>
                     <a:p>
                       <a:pPr algn="ctr">
-                        <a:defRPr sz="1500">
+                        <a:defRPr sz="1400">
                           <a:solidFill>
                             <a:srgbClr val="FFFFFF"/>
                           </a:solidFill>
@@ -8593,7 +8870,7 @@
                         </a:defRPr>
                       </a:pPr>
                       <a:r>
-                        <a:t>Inference Latency</a:t>
+                        <a:t>Serial back to Arduino</a:t>
                       </a:r>
                     </a:p>
                   </a:txBody>
@@ -8609,7 +8886,7 @@
                     <a:lstStyle/>
                     <a:p>
                       <a:pPr algn="ctr">
-                        <a:defRPr sz="1500">
+                        <a:defRPr sz="1400">
                           <a:solidFill>
                             <a:srgbClr val="FFFFFF"/>
                           </a:solidFill>
@@ -8617,7 +8894,7 @@
                         </a:defRPr>
                       </a:pPr>
                       <a:r>
-                        <a:t>&lt; 30 ms per window</a:t>
+                        <a:t>~3 ms</a:t>
                       </a:r>
                     </a:p>
                   </a:txBody>
@@ -8628,14 +8905,14 @@
                   </a:tcPr>
                 </a:tc>
               </a:tr>
-              <a:tr h="514350">
+              <a:tr h="222885">
                 <a:tc>
                   <a:txBody>
                     <a:bodyPr/>
                     <a:lstStyle/>
                     <a:p>
                       <a:pPr algn="ctr">
-                        <a:defRPr sz="1500">
+                        <a:defRPr sz="1400">
                           <a:solidFill>
                             <a:srgbClr val="FFFFFF"/>
                           </a:solidFill>
@@ -8643,7 +8920,7 @@
                         </a:defRPr>
                       </a:pPr>
                       <a:r>
-                        <a:t>Total Loop Time</a:t>
+                        <a:t>‣ Total end-to-end</a:t>
                       </a:r>
                     </a:p>
                   </a:txBody>
@@ -8659,7 +8936,7 @@
                     <a:lstStyle/>
                     <a:p>
                       <a:pPr algn="ctr">
-                        <a:defRPr sz="1500">
+                        <a:defRPr sz="1400">
                           <a:solidFill>
                             <a:srgbClr val="FFFFFF"/>
                           </a:solidFill>
@@ -8667,7 +8944,7 @@
                         </a:defRPr>
                       </a:pPr>
                       <a:r>
-                        <a:t>&lt; 50 ms (20 Hz update)</a:t>
+                        <a:t>~45–55 ms</a:t>
                       </a:r>
                     </a:p>
                   </a:txBody>
@@ -8678,14 +8955,14 @@
                   </a:tcPr>
                 </a:tc>
               </a:tr>
-              <a:tr h="514350">
+              <a:tr h="222885">
                 <a:tc>
                   <a:txBody>
                     <a:bodyPr/>
                     <a:lstStyle/>
                     <a:p>
                       <a:pPr algn="ctr">
-                        <a:defRPr sz="1500">
+                        <a:defRPr sz="1400">
                           <a:solidFill>
                             <a:srgbClr val="FFFFFF"/>
                           </a:solidFill>
@@ -8693,7 +8970,7 @@
                         </a:defRPr>
                       </a:pPr>
                       <a:r>
-                        <a:t>Model Parameters</a:t>
+                        <a:t>Update rate</a:t>
                       </a:r>
                     </a:p>
                   </a:txBody>
@@ -8709,7 +8986,7 @@
                     <a:lstStyle/>
                     <a:p>
                       <a:pPr algn="ctr">
-                        <a:defRPr sz="1500">
+                        <a:defRPr sz="1400">
                           <a:solidFill>
                             <a:srgbClr val="FFFFFF"/>
                           </a:solidFill>
@@ -8717,7 +8994,7 @@
                         </a:defRPr>
                       </a:pPr>
                       <a:r>
-                        <a:t>23,809 (float32)</a:t>
+                        <a:t>20–25 Hz</a:t>
                       </a:r>
                     </a:p>
                   </a:txBody>
@@ -8728,14 +9005,14 @@
                   </a:tcPr>
                 </a:tc>
               </a:tr>
-              <a:tr h="514350">
+              <a:tr h="222885">
                 <a:tc>
                   <a:txBody>
                     <a:bodyPr/>
                     <a:lstStyle/>
                     <a:p>
                       <a:pPr algn="ctr">
-                        <a:defRPr sz="1500">
+                        <a:defRPr sz="1400">
                           <a:solidFill>
                             <a:srgbClr val="FFFFFF"/>
                           </a:solidFill>
@@ -8743,7 +9020,7 @@
                         </a:defRPr>
                       </a:pPr>
                       <a:r>
-                        <a:t>Power Consumption</a:t>
+                        <a:t>Acceptable threshold</a:t>
                       </a:r>
                     </a:p>
                   </a:txBody>
@@ -8759,7 +9036,7 @@
                     <a:lstStyle/>
                     <a:p>
                       <a:pPr algn="ctr">
-                        <a:defRPr sz="1500">
+                        <a:defRPr sz="1400">
                           <a:solidFill>
                             <a:srgbClr val="FFFFFF"/>
                           </a:solidFill>
@@ -8767,7 +9044,7 @@
                         </a:defRPr>
                       </a:pPr>
                       <a:r>
-                        <a:t>~500 mW (board + sensors)</a:t>
+                        <a:t>100–300 ms</a:t>
                       </a:r>
                     </a:p>
                   </a:txBody>
@@ -8782,45 +9059,6 @@
           </a:graphicData>
         </a:graphic>
       </p:graphicFrame>
-      <p:sp>
-        <p:nvSpPr>
-          <p:cNvPr id="8" name="TextBox 7"/>
-          <p:cNvSpPr txBox="1"/>
-          <p:nvPr/>
-        </p:nvSpPr>
-        <p:spPr>
-          <a:xfrm>
-            <a:off x="6583680" y="5669280"/>
-            <a:ext cx="5120640" cy="731520"/>
-          </a:xfrm>
-          <a:prstGeom prst="rect">
-            <a:avLst/>
-          </a:prstGeom>
-          <a:noFill/>
-        </p:spPr>
-        <p:txBody>
-          <a:bodyPr wrap="square">
-            <a:spAutoFit/>
-          </a:bodyPr>
-          <a:lstStyle/>
-          <a:p>
-            <a:pPr algn="ctr">
-              <a:spcAft>
-                <a:spcPts val="400"/>
-              </a:spcAft>
-              <a:defRPr sz="1500" b="0">
-                <a:solidFill>
-                  <a:srgbClr val="B0C4DE"/>
-                </a:solidFill>
-                <a:latin typeface="Calibri"/>
-              </a:defRPr>
-            </a:pPr>
-            <a:r>
-              <a:t>PyTorch weights exported as C float arrays for Arduino compilation</a:t>
-            </a:r>
-          </a:p>
-        </p:txBody>
-      </p:sp>
     </p:spTree>
   </p:cSld>
   <p:clrMapOvr>
@@ -10745,7 +10983,7 @@
         </p:nvGraphicFramePr>
         <p:xfrm>
           <a:off x="6858000" y="1280160"/>
-          <a:ext cx="4846320" cy="4754880"/>
+          <a:ext cx="4846320" cy="5212080"/>
         </p:xfrm>
         <a:graphic>
           <a:graphicData uri="http://schemas.openxmlformats.org/drawingml/2006/table">
@@ -10754,10 +10992,10 @@
                 <a:tableStyleId>{5C22544A-7EE6-4342-B048-85BDC9FD1C3A}</a:tableStyleId>
               </a:tblPr>
               <a:tblGrid>
-                <a:gridCol w="2011680"/>
-                <a:gridCol w="2834640"/>
+                <a:gridCol w="2194560"/>
+                <a:gridCol w="2651760"/>
               </a:tblGrid>
-              <a:tr h="594360">
+              <a:tr h="579120">
                 <a:tc>
                   <a:txBody>
                     <a:bodyPr/>
@@ -10807,7 +11045,7 @@
                   </a:tcPr>
                 </a:tc>
               </a:tr>
-              <a:tr h="594360">
+              <a:tr h="579120">
                 <a:tc>
                   <a:txBody>
                     <a:bodyPr/>
@@ -10857,7 +11095,7 @@
                   </a:tcPr>
                 </a:tc>
               </a:tr>
-              <a:tr h="594360">
+              <a:tr h="579120">
                 <a:tc>
                   <a:txBody>
                     <a:bodyPr/>
@@ -10896,7 +11134,7 @@
                         </a:defRPr>
                       </a:pPr>
                       <a:r>
-                        <a:t>Linear actuators + nylon strings</a:t>
+                        <a:t>5× linear actuators + nylon strings</a:t>
                       </a:r>
                     </a:p>
                   </a:txBody>
@@ -10907,7 +11145,7 @@
                   </a:tcPr>
                 </a:tc>
               </a:tr>
-              <a:tr h="594360">
+              <a:tr h="579120">
                 <a:tc>
                   <a:txBody>
                     <a:bodyPr/>
@@ -10922,7 +11160,7 @@
                         </a:defRPr>
                       </a:pPr>
                       <a:r>
-                        <a:t>Controller</a:t>
+                        <a:t>Inference Board</a:t>
                       </a:r>
                     </a:p>
                   </a:txBody>
@@ -10946,7 +11184,7 @@
                         </a:defRPr>
                       </a:pPr>
                       <a:r>
-                        <a:t>Arduino Mega 2560</a:t>
+                        <a:t>Raspberry Pi 3 (ARMv8, 1.2 GHz)</a:t>
                       </a:r>
                     </a:p>
                   </a:txBody>
@@ -10957,7 +11195,7 @@
                   </a:tcPr>
                 </a:tc>
               </a:tr>
-              <a:tr h="594360">
+              <a:tr h="579120">
                 <a:tc>
                   <a:txBody>
                     <a:bodyPr/>
@@ -10972,7 +11210,7 @@
                         </a:defRPr>
                       </a:pPr>
                       <a:r>
-                        <a:t>EMG Sensors</a:t>
+                        <a:t>ADC + Actuator MCU</a:t>
                       </a:r>
                     </a:p>
                   </a:txBody>
@@ -10996,7 +11234,7 @@
                         </a:defRPr>
                       </a:pPr>
                       <a:r>
-                        <a:t>2× MyoWare 2.0</a:t>
+                        <a:t>Arduino Mega 2560</a:t>
                       </a:r>
                     </a:p>
                   </a:txBody>
@@ -11007,7 +11245,7 @@
                   </a:tcPr>
                 </a:tc>
               </a:tr>
-              <a:tr h="594360">
+              <a:tr h="579120">
                 <a:tc>
                   <a:txBody>
                     <a:bodyPr/>
@@ -11022,7 +11260,7 @@
                         </a:defRPr>
                       </a:pPr>
                       <a:r>
-                        <a:t>Channels</a:t>
+                        <a:t>EMG Sensors</a:t>
                       </a:r>
                     </a:p>
                   </a:txBody>
@@ -11046,7 +11284,7 @@
                         </a:defRPr>
                       </a:pPr>
                       <a:r>
-                        <a:t>2 (ECRB Ch5, ECU Ch3)</a:t>
+                        <a:t>2× MyoWare 2.0</a:t>
                       </a:r>
                     </a:p>
                   </a:txBody>
@@ -11057,7 +11295,7 @@
                   </a:tcPr>
                 </a:tc>
               </a:tr>
-              <a:tr h="594360">
+              <a:tr h="579120">
                 <a:tc>
                   <a:txBody>
                     <a:bodyPr/>
@@ -11072,7 +11310,7 @@
                         </a:defRPr>
                       </a:pPr>
                       <a:r>
-                        <a:t>Sampling Rate</a:t>
+                        <a:t>Channels</a:t>
                       </a:r>
                     </a:p>
                   </a:txBody>
@@ -11096,7 +11334,7 @@
                         </a:defRPr>
                       </a:pPr>
                       <a:r>
-                        <a:t>200 Hz (Myo armband)</a:t>
+                        <a:t>2 (ECRB Ch5, ECU Ch3)</a:t>
                       </a:r>
                     </a:p>
                   </a:txBody>
@@ -11107,7 +11345,7 @@
                   </a:tcPr>
                 </a:tc>
               </a:tr>
-              <a:tr h="594360">
+              <a:tr h="579120">
                 <a:tc>
                   <a:txBody>
                     <a:bodyPr/>
@@ -11122,7 +11360,7 @@
                         </a:defRPr>
                       </a:pPr>
                       <a:r>
-                        <a:t>Model Size</a:t>
+                        <a:t>Sampling Rate</a:t>
                       </a:r>
                     </a:p>
                   </a:txBody>
@@ -11146,13 +11384,63 @@
                         </a:defRPr>
                       </a:pPr>
                       <a:r>
+                        <a:t>200 Hz (Myo armband dataset)</a:t>
+                      </a:r>
+                    </a:p>
+                  </a:txBody>
+                  <a:tcPr anchor="ctr">
+                    <a:solidFill>
+                      <a:srgbClr val="223A5E"/>
+                    </a:solidFill>
+                  </a:tcPr>
+                </a:tc>
+              </a:tr>
+              <a:tr h="579120">
+                <a:tc>
+                  <a:txBody>
+                    <a:bodyPr/>
+                    <a:lstStyle/>
+                    <a:p>
+                      <a:pPr algn="ctr">
+                        <a:defRPr sz="1500">
+                          <a:solidFill>
+                            <a:srgbClr val="FFFFFF"/>
+                          </a:solidFill>
+                          <a:latin typeface="Calibri"/>
+                        </a:defRPr>
+                      </a:pPr>
+                      <a:r>
+                        <a:t>Model Size</a:t>
+                      </a:r>
+                    </a:p>
+                  </a:txBody>
+                  <a:tcPr anchor="ctr">
+                    <a:solidFill>
+                      <a:srgbClr val="14203A"/>
+                    </a:solidFill>
+                  </a:tcPr>
+                </a:tc>
+                <a:tc>
+                  <a:txBody>
+                    <a:bodyPr/>
+                    <a:lstStyle/>
+                    <a:p>
+                      <a:pPr algn="ctr">
+                        <a:defRPr sz="1500">
+                          <a:solidFill>
+                            <a:srgbClr val="FFFFFF"/>
+                          </a:solidFill>
+                          <a:latin typeface="Calibri"/>
+                        </a:defRPr>
+                      </a:pPr>
+                      <a:r>
                         <a:t>23,809 parameters</a:t>
                       </a:r>
                     </a:p>
                   </a:txBody>
                   <a:tcPr anchor="ctr">
                     <a:solidFill>
-                      <a:srgbClr val="223A5E"/>
+                      <a:srgbClr val="14203A"/>
                     </a:solidFill>
                   </a:tcPr>
                 </a:tc>

</xml_diff>